<commit_message>
Programação diária das redes: semana 17–23/10 para aprovação
- A partir de 17/10: feed em dias alternados + story todo dia (calendário com 22 peças).
- Novo no Kit: 18/10 (opções A e B); stories de 19, 21 e 23/10 no calendário.
- scripts/gerar_programacao.py: página /programacao (dia a dia, código por peça,
  legenda com cópia, aprovação montada na página), 14 stories em PNG 1080×1920,
  pacote de agendamento por dia, md e PDF para enviar à prof.ª.
- Site do calendário ganha o card "Programação da semana".
- Termos do plano antigo (18 peças, 3x/semana) registrados em obsoletos.txt.

Co-Authored-By: Claude Opus 5.5 <noreply@anthropic.com>
Claude-Session: https://claude.ai/code/session_01GKKoM8obanXNdrevJ4Sbmv
</commit_message>
<xml_diff>
--- a/entregas/posts/site/kit/editavel/efeito-rebote-sex-09-10-opcao-b.pptx
+++ b/entregas/posts/site/kit/editavel/efeito-rebote-sex-09-10-opcao-b.pptx
@@ -6647,7 +6647,7 @@
         <p:spPr>
           <a:xfrm>
             <a:off x="915442" y="3567811"/>
-            <a:ext cx="8559864" cy="1867049"/>
+            <a:ext cx="6652959" cy="1867049"/>
           </a:xfrm>
           <a:prstGeom prst="rect">
             <a:avLst/>
@@ -6680,7 +6680,7 @@
                 <a:ea typeface="Barlow Condensed"/>
                 <a:cs typeface="Barlow Condensed"/>
               </a:rPr>
-              <a:t>Um tema com fonte,</a:t>
+              <a:t>Um tema com</a:t>
             </a:r>
             <a:br/>
             <a:r>
@@ -6692,7 +6692,7 @@
                 <a:ea typeface="Barlow Condensed"/>
                 <a:cs typeface="Barlow Condensed"/>
               </a:rPr>
-              <a:t>três vezes por semana.</a:t>
+              <a:t>fonte a cada post.</a:t>
             </a:r>
           </a:p>
         </p:txBody>

</xml_diff>